<commit_message>
Clean up law sample output
</commit_message>
<xml_diff>
--- a/sample_outputs/law-slides.pptx
+++ b/sample_outputs/law-slides.pptx
@@ -8,8 +8,6 @@
     <p:sldId id="256" r:id="rId7"/>
     <p:sldId id="257" r:id="rId8"/>
     <p:sldId id="258" r:id="rId9"/>
-    <p:sldId id="259" r:id="rId10"/>
-    <p:sldId id="260" r:id="rId11"/>
   </p:sldIdLst>
   <p:sldSz cx="12188952" cy="6858000" type="screen4x3"/>
   <p:notesSz cx="6858000" cy="9144000"/>
@@ -3102,13 +3100,19 @@
             <p:ph type="ctrTitle"/>
           </p:nvPr>
         </p:nvSpPr>
-        <p:spPr/>
-        <p:txBody>
-          <a:bodyPr/>
-          <a:lstStyle/>
-          <a:p>
-            <a:r>
-              <a:t>Psychology Lecture: Introduction to Cognitive Biases</a:t>
+        <p:spPr>
+          <a:xfrm>
+            <a:off x="0" y="2286000"/>
+            <a:ext cx="12188952" cy="0"/>
+          </a:xfrm>
+        </p:spPr>
+        <p:txBody>
+          <a:bodyPr/>
+          <a:lstStyle/>
+          <a:p>
+            <a:pPr algn="ctr"/>
+            <a:r>
+              <a:t>Law Lecture</a:t>
             </a:r>
           </a:p>
         </p:txBody>
@@ -3123,13 +3127,19 @@
             <p:ph type="subTitle" idx="1"/>
           </p:nvPr>
         </p:nvSpPr>
-        <p:spPr/>
-        <p:txBody>
-          <a:bodyPr/>
-          <a:lstStyle/>
-          <a:p>
-            <a:r>
-              <a:t>2026-06-07</a:t>
+        <p:spPr>
+          <a:xfrm>
+            <a:off x="0" y="3200400"/>
+            <a:ext cx="12188952" cy="0"/>
+          </a:xfrm>
+        </p:spPr>
+        <p:txBody>
+          <a:bodyPr/>
+          <a:lstStyle/>
+          <a:p>
+            <a:pPr algn="ctr"/>
+            <a:r>
+              <a:t>2026-06-08</a:t>
             </a:r>
           </a:p>
         </p:txBody>
@@ -3162,13 +3172,19 @@
             <p:ph type="title"/>
           </p:nvPr>
         </p:nvSpPr>
-        <p:spPr/>
-        <p:txBody>
-          <a:bodyPr/>
-          <a:lstStyle/>
-          <a:p>
-            <a:r>
-              <a:t>What Are Cognitive Biases?</a:t>
+        <p:spPr>
+          <a:xfrm>
+            <a:off x="0" y="365760"/>
+            <a:ext cx="12188952" cy="0"/>
+          </a:xfrm>
+        </p:spPr>
+        <p:txBody>
+          <a:bodyPr/>
+          <a:lstStyle/>
+          <a:p>
+            <a:pPr algn="ctr"/>
+            <a:r>
+              <a:t>Key Points</a:t>
             </a:r>
           </a:p>
         </p:txBody>
@@ -3192,7 +3208,7 @@
               <a:defRPr sz="1800"/>
             </a:pPr>
             <a:r>
-              <a:t>Systematic errors in thinking that affect decisions and judgements</a:t>
+              <a:t>The lecturer will introduce equal protection rights and explain their origin.</a:t>
             </a:r>
           </a:p>
           <a:p>
@@ -3200,7 +3216,7 @@
               <a:defRPr sz="1800"/>
             </a:pPr>
             <a:r>
-              <a:t>Arise from mental shortcuts (heuristics) the brain uses to process information</a:t>
+              <a:t>The lecturer will discuss the meaning and rule of equal protection rights.</a:t>
             </a:r>
           </a:p>
           <a:p>
@@ -3208,7 +3224,23 @@
               <a:defRPr sz="1800"/>
             </a:pPr>
             <a:r>
-              <a:t>Universal — affect everyone regardless of intelligence</a:t>
+              <a:t>The lecturer will provide examples of equal protection rights and their applications.</a:t>
+            </a:r>
+          </a:p>
+          <a:p>
+            <a:pPr>
+              <a:defRPr sz="1800"/>
+            </a:pPr>
+            <a:r>
+              <a:t>The lecturer will compare the facts in the bar question with examples of equal protection rights.</a:t>
+            </a:r>
+          </a:p>
+          <a:p>
+            <a:pPr>
+              <a:defRPr sz="1800"/>
+            </a:pPr>
+            <a:r>
+              <a:t>The lecturer will make a decision about whether equal protection rights have been valid.</a:t>
             </a:r>
           </a:p>
         </p:txBody>
@@ -3241,13 +3273,19 @@
             <p:ph type="title"/>
           </p:nvPr>
         </p:nvSpPr>
-        <p:spPr/>
-        <p:txBody>
-          <a:bodyPr/>
-          <a:lstStyle/>
-          <a:p>
-            <a:r>
-              <a:t>Confirmation Bias</a:t>
+        <p:spPr>
+          <a:xfrm>
+            <a:off x="0" y="365760"/>
+            <a:ext cx="12188952" cy="0"/>
+          </a:xfrm>
+        </p:spPr>
+        <p:txBody>
+          <a:bodyPr/>
+          <a:lstStyle/>
+          <a:p>
+            <a:pPr algn="ctr"/>
+            <a:r>
+              <a:t>Summary</a:t>
             </a:r>
           </a:p>
         </p:txBody>
@@ -3271,181 +3309,7 @@
               <a:defRPr sz="1800"/>
             </a:pPr>
             <a:r>
-              <a:t>Tendency to search for information that confirms existing beliefs</a:t>
-            </a:r>
-          </a:p>
-          <a:p>
-            <a:pPr>
-              <a:defRPr sz="1800"/>
-            </a:pPr>
-            <a:r>
-              <a:t>Leads to ignoring contradictory evidence</a:t>
-            </a:r>
-          </a:p>
-          <a:p>
-            <a:pPr>
-              <a:defRPr sz="1800"/>
-            </a:pPr>
-            <a:r>
-              <a:t>Common in politics, science, and everyday decisions</a:t>
-            </a:r>
-          </a:p>
-        </p:txBody>
-      </p:sp>
-    </p:spTree>
-  </p:cSld>
-  <p:clrMapOvr>
-    <a:masterClrMapping/>
-  </p:clrMapOvr>
-</p:sld>
-</file>
-
-<file path=ppt/slides/slide4.xml><?xml version="1.0" encoding="utf-8"?>
-<p:sld xmlns:a="http://schemas.openxmlformats.org/drawingml/2006/main" xmlns:p="http://schemas.openxmlformats.org/presentationml/2006/main" xmlns:r="http://schemas.openxmlformats.org/officeDocument/2006/relationships">
-  <p:cSld>
-    <p:spTree>
-      <p:nvGrpSpPr>
-        <p:cNvPr id="1" name=""/>
-        <p:cNvGrpSpPr/>
-        <p:nvPr/>
-      </p:nvGrpSpPr>
-      <p:grpSpPr/>
-      <p:sp>
-        <p:nvSpPr>
-          <p:cNvPr id="2" name="Title 1"/>
-          <p:cNvSpPr>
-            <a:spLocks noGrp="1"/>
-          </p:cNvSpPr>
-          <p:nvPr>
-            <p:ph type="title"/>
-          </p:nvPr>
-        </p:nvSpPr>
-        <p:spPr/>
-        <p:txBody>
-          <a:bodyPr/>
-          <a:lstStyle/>
-          <a:p>
-            <a:r>
-              <a:t>Availability Heuristic</a:t>
-            </a:r>
-          </a:p>
-        </p:txBody>
-      </p:sp>
-      <p:sp>
-        <p:nvSpPr>
-          <p:cNvPr id="3" name="Content Placeholder 2"/>
-          <p:cNvSpPr>
-            <a:spLocks noGrp="1"/>
-          </p:cNvSpPr>
-          <p:nvPr>
-            <p:ph idx="1"/>
-          </p:nvPr>
-        </p:nvSpPr>
-        <p:spPr/>
-        <p:txBody>
-          <a:bodyPr/>
-          <a:lstStyle/>
-          <a:p>
-            <a:pPr>
-              <a:defRPr sz="1800"/>
-            </a:pPr>
-            <a:r>
-              <a:t>Judging probability by how easily examples come to mind</a:t>
-            </a:r>
-          </a:p>
-          <a:p>
-            <a:pPr>
-              <a:defRPr sz="1800"/>
-            </a:pPr>
-            <a:r>
-              <a:t>Vivid or recent events feel more likely than statistics suggest</a:t>
-            </a:r>
-          </a:p>
-          <a:p>
-            <a:pPr>
-              <a:defRPr sz="1800"/>
-            </a:pPr>
-            <a:r>
-              <a:t>Example: overestimating plane crash risk after seeing news coverage</a:t>
-            </a:r>
-          </a:p>
-        </p:txBody>
-      </p:sp>
-    </p:spTree>
-  </p:cSld>
-  <p:clrMapOvr>
-    <a:masterClrMapping/>
-  </p:clrMapOvr>
-</p:sld>
-</file>
-
-<file path=ppt/slides/slide5.xml><?xml version="1.0" encoding="utf-8"?>
-<p:sld xmlns:a="http://schemas.openxmlformats.org/drawingml/2006/main" xmlns:p="http://schemas.openxmlformats.org/presentationml/2006/main" xmlns:r="http://schemas.openxmlformats.org/officeDocument/2006/relationships">
-  <p:cSld>
-    <p:spTree>
-      <p:nvGrpSpPr>
-        <p:cNvPr id="1" name=""/>
-        <p:cNvGrpSpPr/>
-        <p:nvPr/>
-      </p:nvGrpSpPr>
-      <p:grpSpPr/>
-      <p:sp>
-        <p:nvSpPr>
-          <p:cNvPr id="2" name="Title 1"/>
-          <p:cNvSpPr>
-            <a:spLocks noGrp="1"/>
-          </p:cNvSpPr>
-          <p:nvPr>
-            <p:ph type="title"/>
-          </p:nvPr>
-        </p:nvSpPr>
-        <p:spPr/>
-        <p:txBody>
-          <a:bodyPr/>
-          <a:lstStyle/>
-          <a:p>
-            <a:r>
-              <a:t>Anchoring Bias</a:t>
-            </a:r>
-          </a:p>
-        </p:txBody>
-      </p:sp>
-      <p:sp>
-        <p:nvSpPr>
-          <p:cNvPr id="3" name="Content Placeholder 2"/>
-          <p:cNvSpPr>
-            <a:spLocks noGrp="1"/>
-          </p:cNvSpPr>
-          <p:nvPr>
-            <p:ph idx="1"/>
-          </p:nvPr>
-        </p:nvSpPr>
-        <p:spPr/>
-        <p:txBody>
-          <a:bodyPr/>
-          <a:lstStyle/>
-          <a:p>
-            <a:pPr>
-              <a:defRPr sz="1800"/>
-            </a:pPr>
-            <a:r>
-              <a:t>First piece of information seen disproportionately influences judgement</a:t>
-            </a:r>
-          </a:p>
-          <a:p>
-            <a:pPr>
-              <a:defRPr sz="1800"/>
-            </a:pPr>
-            <a:r>
-              <a:t>Used heavily in negotiation and pricing strategies</a:t>
-            </a:r>
-          </a:p>
-          <a:p>
-            <a:pPr>
-              <a:defRPr sz="1800"/>
-            </a:pPr>
-            <a:r>
-              <a:t>Hard to overcome even when we know about it</a:t>
+              <a:t>The lecturer will discuss the origin and meaning of equal protection rights, provide examples of their application, and compare these examples with the facts in a bar question. The lecturer will then make a decision about whether equal protection rights have been valid based on these examples.</a:t>
             </a:r>
           </a:p>
         </p:txBody>

</xml_diff>